<commit_message>
corrected typos in slides of week 4
</commit_message>
<xml_diff>
--- a/Live-lecture-slides/CITS5503Virtualization_DynamoDB_week4.pptx
+++ b/Live-lecture-slides/CITS5503Virtualization_DynamoDB_week4.pptx
@@ -11492,7 +11492,7 @@
                   <a:schemeClr val="tx1"/>
                 </a:solidFill>
               </a:rPr>
-              <a:t>4KB</a:t>
+              <a:t>4KiB</a:t>
             </a:r>
           </a:p>
         </p:txBody>
@@ -11650,7 +11650,7 @@
                   <a:schemeClr val="tx1"/>
                 </a:solidFill>
               </a:rPr>
-              <a:t>4KB</a:t>
+              <a:t>4KiB</a:t>
             </a:r>
           </a:p>
         </p:txBody>
@@ -11961,7 +11961,7 @@
                   <a:schemeClr val="tx1"/>
                 </a:solidFill>
               </a:rPr>
-              <a:t>4KB</a:t>
+              <a:t>4KiB</a:t>
             </a:r>
           </a:p>
         </p:txBody>
@@ -12119,7 +12119,7 @@
                   <a:schemeClr val="tx1"/>
                 </a:solidFill>
               </a:rPr>
-              <a:t>4KB</a:t>
+              <a:t>4KiB</a:t>
             </a:r>
           </a:p>
         </p:txBody>
@@ -12671,8 +12671,8 @@
         </p:nvSpPr>
         <p:spPr>
           <a:xfrm>
-            <a:off x="580014" y="210755"/>
-            <a:ext cx="3760581" cy="584775"/>
+            <a:off x="732908" y="210755"/>
+            <a:ext cx="3454792" cy="584775"/>
           </a:xfrm>
           <a:prstGeom prst="rect">
             <a:avLst/>
@@ -12686,26 +12686,35 @@
           <a:lstStyle/>
           <a:p>
             <a:r>
-              <a:rPr lang="en-AU" sz="3200" dirty="0">
+              <a:rPr lang="en-AU" sz="3200" b="1" dirty="0">
                 <a:solidFill>
                   <a:srgbClr val="000000"/>
                 </a:solidFill>
+                <a:latin typeface="+mj-lt"/>
+                <a:ea typeface="+mj-ea"/>
+                <a:cs typeface="+mj-cs"/>
               </a:rPr>
               <a:t>V</a:t>
             </a:r>
             <a:r>
-              <a:rPr sz="3200" dirty="0" err="1">
+              <a:rPr sz="3200" b="1" dirty="0" err="1">
                 <a:solidFill>
                   <a:srgbClr val="000000"/>
                 </a:solidFill>
+                <a:latin typeface="+mj-lt"/>
+                <a:ea typeface="+mj-ea"/>
+                <a:cs typeface="+mj-cs"/>
               </a:rPr>
               <a:t>irtual</a:t>
             </a:r>
             <a:r>
-              <a:rPr sz="3200" dirty="0">
+              <a:rPr sz="3200" b="1" dirty="0">
                 <a:solidFill>
                   <a:srgbClr val="000000"/>
                 </a:solidFill>
+                <a:latin typeface="+mj-lt"/>
+                <a:ea typeface="+mj-ea"/>
+                <a:cs typeface="+mj-cs"/>
               </a:rPr>
               <a:t> memory size</a:t>
             </a:r>
@@ -13225,8 +13234,8 @@
         </p:nvSpPr>
         <p:spPr>
           <a:xfrm>
-            <a:off x="573001" y="173736"/>
-            <a:ext cx="4029501" cy="584775"/>
+            <a:off x="788733" y="173736"/>
+            <a:ext cx="3598036" cy="584775"/>
           </a:xfrm>
           <a:prstGeom prst="rect">
             <a:avLst/>
@@ -13240,26 +13249,35 @@
           <a:lstStyle/>
           <a:p>
             <a:r>
-              <a:rPr lang="en-AU" sz="3200" dirty="0">
+              <a:rPr lang="en-AU" sz="3200" b="1" dirty="0">
                 <a:solidFill>
                   <a:srgbClr val="000000"/>
                 </a:solidFill>
+                <a:latin typeface="+mj-lt"/>
+                <a:ea typeface="+mj-ea"/>
+                <a:cs typeface="+mj-cs"/>
               </a:rPr>
               <a:t>P</a:t>
             </a:r>
             <a:r>
-              <a:rPr sz="3200" dirty="0" err="1">
+              <a:rPr sz="3200" b="1" dirty="0" err="1">
                 <a:solidFill>
                   <a:srgbClr val="000000"/>
                 </a:solidFill>
+                <a:latin typeface="+mj-lt"/>
+                <a:ea typeface="+mj-ea"/>
+                <a:cs typeface="+mj-cs"/>
               </a:rPr>
               <a:t>hysical</a:t>
             </a:r>
             <a:r>
-              <a:rPr sz="3200" dirty="0">
+              <a:rPr sz="3200" b="1" dirty="0">
                 <a:solidFill>
                   <a:srgbClr val="000000"/>
                 </a:solidFill>
+                <a:latin typeface="+mj-lt"/>
+                <a:ea typeface="+mj-ea"/>
+                <a:cs typeface="+mj-cs"/>
               </a:rPr>
               <a:t> memory size</a:t>
             </a:r>
@@ -16557,7 +16575,11 @@
               </a:rPr>
               <a:t>On-demand Paging</a:t>
             </a:r>
-            <a:endParaRPr lang="en-US" sz="3200" b="1" dirty="0"/>
+            <a:endParaRPr lang="en-US" sz="3200" b="1" dirty="0">
+              <a:solidFill>
+                <a:srgbClr val="000000"/>
+              </a:solidFill>
+            </a:endParaRPr>
           </a:p>
         </p:txBody>
       </p:sp>
@@ -16618,7 +16640,7 @@
                   <a:srgbClr val="FF0000"/>
                 </a:solidFill>
               </a:rPr>
-              <a:t>Crash?</a:t>
+              <a:t>Not a crash</a:t>
             </a:r>
             <a:endParaRPr b="1" dirty="0">
               <a:solidFill>
@@ -16712,7 +16734,7 @@
         <p:spPr>
           <a:xfrm>
             <a:off x="320040" y="182880"/>
-            <a:ext cx="11430000" cy="584775"/>
+            <a:ext cx="11430000" cy="521681"/>
           </a:xfrm>
           <a:prstGeom prst="rect">
             <a:avLst/>
@@ -16725,12 +16747,27 @@
           </a:bodyPr>
           <a:lstStyle/>
           <a:p>
-            <a:pPr algn="l"/>
-            <a:r>
-              <a:rPr sz="3200" dirty="0">
-                <a:solidFill>
-                  <a:srgbClr val="282828"/>
-                </a:solidFill>
+            <a:pPr algn="l" fontAlgn="auto">
+              <a:lnSpc>
+                <a:spcPct val="90000"/>
+              </a:lnSpc>
+              <a:spcBef>
+                <a:spcPct val="0"/>
+              </a:spcBef>
+              <a:spcAft>
+                <a:spcPts val="0"/>
+              </a:spcAft>
+              <a:buClrTx/>
+              <a:buSzTx/>
+            </a:pPr>
+            <a:r>
+              <a:rPr sz="3100" b="1" dirty="0">
+                <a:solidFill>
+                  <a:srgbClr val="000000"/>
+                </a:solidFill>
+                <a:latin typeface="+mj-lt"/>
+                <a:ea typeface="+mj-ea"/>
+                <a:cs typeface="+mj-cs"/>
               </a:rPr>
               <a:t>Page fault</a:t>
             </a:r>
@@ -19204,7 +19241,11 @@
               </a:rPr>
               <a:t>On-demand Paging</a:t>
             </a:r>
-            <a:endParaRPr lang="en-US" sz="3200" b="1" dirty="0"/>
+            <a:endParaRPr lang="en-US" sz="3200" b="1" dirty="0">
+              <a:solidFill>
+                <a:srgbClr val="000000"/>
+              </a:solidFill>
+            </a:endParaRPr>
           </a:p>
         </p:txBody>
       </p:sp>
@@ -20371,17 +20412,20 @@
               </a:spcAft>
               <a:buClrTx/>
               <a:buSzTx/>
-              <a:buFontTx/>
             </a:pPr>
             <a:r>
-              <a:rPr lang="en-AU" sz="3200" b="1" dirty="0">
+              <a:rPr lang="en-AU" sz="3100" b="1" dirty="0">
                 <a:solidFill>
                   <a:srgbClr val="000000"/>
                 </a:solidFill>
               </a:rPr>
               <a:t>On-demand Paging</a:t>
             </a:r>
-            <a:endParaRPr lang="en-US" sz="3200" b="1" dirty="0"/>
+            <a:endParaRPr lang="en-US" sz="3100" b="1" dirty="0">
+              <a:solidFill>
+                <a:srgbClr val="000000"/>
+              </a:solidFill>
+            </a:endParaRPr>
           </a:p>
         </p:txBody>
       </p:sp>
@@ -20815,7 +20859,7 @@
                 </a:solidFill>
                 <a:latin typeface="Arial"/>
               </a:rPr>
-              <a:t> to swap slot 3</a:t>
+              <a:t> to disk swap slot 3</a:t>
             </a:r>
             <a:endParaRPr sz="1100" b="1" dirty="0">
               <a:solidFill>
@@ -21231,13 +21275,22 @@
               <a:t>slot </a:t>
             </a:r>
             <a:r>
+              <a:rPr lang="en-AU" sz="1050" dirty="0">
+                <a:solidFill>
+                  <a:srgbClr val="191919"/>
+                </a:solidFill>
+                <a:latin typeface="Arial"/>
+              </a:rPr>
+              <a:t> </a:t>
+            </a:r>
+            <a:r>
               <a:rPr sz="1050" b="0" dirty="0">
                 <a:solidFill>
                   <a:srgbClr val="191919"/>
                 </a:solidFill>
                 <a:latin typeface="Arial"/>
               </a:rPr>
-              <a:t>S3</a:t>
+              <a:t>3</a:t>
             </a:r>
           </a:p>
         </p:txBody>
@@ -21934,7 +21987,7 @@
         </p:nvSpPr>
         <p:spPr>
           <a:xfrm>
-            <a:off x="307575" y="259740"/>
+            <a:off x="459238" y="328692"/>
             <a:ext cx="8501881" cy="695272"/>
           </a:xfrm>
           <a:prstGeom prst="rect">
@@ -21973,24 +22026,18 @@
               <a:buSzTx/>
             </a:pPr>
             <a:r>
-              <a:rPr lang="en-AU" sz="3300" dirty="0">
+              <a:rPr lang="en-AU" sz="3100" b="1" dirty="0">
                 <a:solidFill>
                   <a:srgbClr val="000000"/>
                 </a:solidFill>
-                <a:latin typeface="Tahoma" pitchFamily="34" charset="0"/>
-                <a:ea typeface="+mn-ea"/>
-                <a:cs typeface="+mn-cs"/>
               </a:rPr>
               <a:t>Swapping: </a:t>
             </a:r>
             <a:r>
-              <a:rPr lang="en-US" sz="3300" dirty="0">
+              <a:rPr lang="en-US" sz="3100" b="1" dirty="0">
                 <a:solidFill>
                   <a:srgbClr val="000000"/>
                 </a:solidFill>
-                <a:latin typeface="Tahoma" pitchFamily="34" charset="0"/>
-                <a:ea typeface="+mn-ea"/>
-                <a:cs typeface="+mn-cs"/>
               </a:rPr>
               <a:t>if memory is full</a:t>
             </a:r>
@@ -22422,7 +22469,7 @@
         <p:spPr>
           <a:xfrm>
             <a:off x="360680" y="70703"/>
-            <a:ext cx="4065921" cy="584775"/>
+            <a:ext cx="3527119" cy="507831"/>
           </a:xfrm>
           <a:prstGeom prst="rect">
             <a:avLst/>
@@ -22435,12 +22482,27 @@
           </a:bodyPr>
           <a:lstStyle/>
           <a:p>
-            <a:pPr algn="l"/>
-            <a:r>
-              <a:rPr sz="3200" dirty="0">
+            <a:pPr algn="l" fontAlgn="auto">
+              <a:lnSpc>
+                <a:spcPct val="90000"/>
+              </a:lnSpc>
+              <a:spcBef>
+                <a:spcPct val="0"/>
+              </a:spcBef>
+              <a:spcAft>
+                <a:spcPts val="0"/>
+              </a:spcAft>
+              <a:buClrTx/>
+              <a:buSzTx/>
+            </a:pPr>
+            <a:r>
+              <a:rPr sz="3000" b="1" dirty="0">
                 <a:solidFill>
                   <a:srgbClr val="000000"/>
                 </a:solidFill>
+                <a:latin typeface="+mj-lt"/>
+                <a:ea typeface="+mj-ea"/>
+                <a:cs typeface="+mj-cs"/>
               </a:rPr>
               <a:t>Memory virtualization</a:t>
             </a:r>
@@ -23523,7 +23585,7 @@
           </a:ln>
           <a:extLst>
             <a:ext uri="{C572A759-6A51-4108-AA02-DFA0A04FC94B}">
-              <ma14:wrappingTextBoxFlag xmlns="" xmlns:m="http://schemas.openxmlformats.org/officeDocument/2006/math" xmlns:a14="http://schemas.microsoft.com/office/drawing/2010/main" xmlns:ma14="http://schemas.microsoft.com/office/mac/drawingml/2011/main" val="1"/>
+              <ma14:wrappingTextBoxFlag xmlns:ma14="http://schemas.microsoft.com/office/mac/drawingml/2011/main" xmlns:a14="http://schemas.microsoft.com/office/drawing/2010/main" xmlns:m="http://schemas.openxmlformats.org/officeDocument/2006/math" xmlns="" val="1"/>
             </a:ext>
           </a:extLst>
         </p:spPr>
@@ -23922,7 +23984,7 @@
           </a:ln>
           <a:extLst>
             <a:ext uri="{C572A759-6A51-4108-AA02-DFA0A04FC94B}">
-              <ma14:wrappingTextBoxFlag xmlns="" xmlns:m="http://schemas.openxmlformats.org/officeDocument/2006/math" xmlns:a14="http://schemas.microsoft.com/office/drawing/2010/main" xmlns:ma14="http://schemas.microsoft.com/office/mac/drawingml/2011/main" val="1"/>
+              <ma14:wrappingTextBoxFlag xmlns:ma14="http://schemas.microsoft.com/office/mac/drawingml/2011/main" xmlns:a14="http://schemas.microsoft.com/office/drawing/2010/main" xmlns:m="http://schemas.openxmlformats.org/officeDocument/2006/math" xmlns="" val="1"/>
             </a:ext>
           </a:extLst>
         </p:spPr>
@@ -23970,7 +24032,7 @@
           </a:ln>
           <a:extLst>
             <a:ext uri="{C572A759-6A51-4108-AA02-DFA0A04FC94B}">
-              <ma14:wrappingTextBoxFlag xmlns="" xmlns:m="http://schemas.openxmlformats.org/officeDocument/2006/math" xmlns:a14="http://schemas.microsoft.com/office/drawing/2010/main" xmlns:ma14="http://schemas.microsoft.com/office/mac/drawingml/2011/main" val="1"/>
+              <ma14:wrappingTextBoxFlag xmlns:ma14="http://schemas.microsoft.com/office/mac/drawingml/2011/main" xmlns:a14="http://schemas.microsoft.com/office/drawing/2010/main" xmlns:m="http://schemas.openxmlformats.org/officeDocument/2006/math" xmlns="" val="1"/>
             </a:ext>
           </a:extLst>
         </p:spPr>
@@ -24018,7 +24080,7 @@
           </a:ln>
           <a:extLst>
             <a:ext uri="{C572A759-6A51-4108-AA02-DFA0A04FC94B}">
-              <ma14:wrappingTextBoxFlag xmlns="" xmlns:m="http://schemas.openxmlformats.org/officeDocument/2006/math" xmlns:a14="http://schemas.microsoft.com/office/drawing/2010/main" xmlns:ma14="http://schemas.microsoft.com/office/mac/drawingml/2011/main" val="1"/>
+              <ma14:wrappingTextBoxFlag xmlns:ma14="http://schemas.microsoft.com/office/mac/drawingml/2011/main" xmlns:a14="http://schemas.microsoft.com/office/drawing/2010/main" xmlns:m="http://schemas.openxmlformats.org/officeDocument/2006/math" xmlns="" val="1"/>
             </a:ext>
           </a:extLst>
         </p:spPr>
@@ -24093,7 +24155,7 @@
           </a:ln>
           <a:extLst>
             <a:ext uri="{C572A759-6A51-4108-AA02-DFA0A04FC94B}">
-              <ma14:wrappingTextBoxFlag xmlns="" xmlns:m="http://schemas.openxmlformats.org/officeDocument/2006/math" xmlns:a14="http://schemas.microsoft.com/office/drawing/2010/main" xmlns:ma14="http://schemas.microsoft.com/office/mac/drawingml/2011/main" val="1"/>
+              <ma14:wrappingTextBoxFlag xmlns:ma14="http://schemas.microsoft.com/office/mac/drawingml/2011/main" xmlns:a14="http://schemas.microsoft.com/office/drawing/2010/main" xmlns:m="http://schemas.openxmlformats.org/officeDocument/2006/math" xmlns="" val="1"/>
             </a:ext>
           </a:extLst>
         </p:spPr>
@@ -24141,7 +24203,7 @@
           </a:ln>
           <a:extLst>
             <a:ext uri="{C572A759-6A51-4108-AA02-DFA0A04FC94B}">
-              <ma14:wrappingTextBoxFlag xmlns="" xmlns:m="http://schemas.openxmlformats.org/officeDocument/2006/math" xmlns:a14="http://schemas.microsoft.com/office/drawing/2010/main" xmlns:ma14="http://schemas.microsoft.com/office/mac/drawingml/2011/main" val="1"/>
+              <ma14:wrappingTextBoxFlag xmlns:ma14="http://schemas.microsoft.com/office/mac/drawingml/2011/main" xmlns:a14="http://schemas.microsoft.com/office/drawing/2010/main" xmlns:m="http://schemas.openxmlformats.org/officeDocument/2006/math" xmlns="" val="1"/>
             </a:ext>
           </a:extLst>
         </p:spPr>
@@ -24221,7 +24283,7 @@
           </a:ln>
           <a:extLst>
             <a:ext uri="{C572A759-6A51-4108-AA02-DFA0A04FC94B}">
-              <ma14:wrappingTextBoxFlag xmlns="" xmlns:m="http://schemas.openxmlformats.org/officeDocument/2006/math" xmlns:a14="http://schemas.microsoft.com/office/drawing/2010/main" xmlns:ma14="http://schemas.microsoft.com/office/mac/drawingml/2011/main" val="1"/>
+              <ma14:wrappingTextBoxFlag xmlns:ma14="http://schemas.microsoft.com/office/mac/drawingml/2011/main" xmlns:a14="http://schemas.microsoft.com/office/drawing/2010/main" xmlns:m="http://schemas.openxmlformats.org/officeDocument/2006/math" xmlns="" val="1"/>
             </a:ext>
           </a:extLst>
         </p:spPr>
@@ -25916,11 +25978,22 @@
           </a:bodyPr>
           <a:lstStyle/>
           <a:p>
-            <a:r>
-              <a:rPr lang="en-AU" sz="2800" b="1" dirty="0"/>
+            <a:pPr>
+              <a:buFont typeface="Wingdings" pitchFamily="2" charset="2"/>
+            </a:pPr>
+            <a:r>
+              <a:rPr lang="en-AU" sz="3000" b="1" dirty="0">
+                <a:solidFill>
+                  <a:srgbClr val="000000"/>
+                </a:solidFill>
+              </a:rPr>
               <a:t>Memory Virtualization</a:t>
             </a:r>
-            <a:endParaRPr sz="2800" b="1" dirty="0"/>
+            <a:endParaRPr sz="3000" b="1" dirty="0">
+              <a:solidFill>
+                <a:srgbClr val="000000"/>
+              </a:solidFill>
+            </a:endParaRPr>
           </a:p>
         </p:txBody>
       </p:sp>
@@ -25963,7 +26036,7 @@
         <p:spPr>
           <a:xfrm>
             <a:off x="411480" y="228600"/>
-            <a:ext cx="4792915" cy="584775"/>
+            <a:ext cx="4216860" cy="553998"/>
           </a:xfrm>
           <a:prstGeom prst="rect">
             <a:avLst/>
@@ -25978,33 +26051,45 @@
           <a:p>
             <a:pPr algn="l"/>
             <a:r>
-              <a:rPr lang="en-AU" sz="3200" dirty="0">
+              <a:rPr lang="en-AU" sz="3000" b="1" dirty="0">
                 <a:solidFill>
                   <a:srgbClr val="000000"/>
                 </a:solidFill>
+                <a:latin typeface="+mj-lt"/>
+                <a:ea typeface="+mj-ea"/>
+                <a:cs typeface="+mj-cs"/>
               </a:rPr>
               <a:t>M</a:t>
             </a:r>
             <a:r>
-              <a:rPr sz="3200" dirty="0" err="1">
+              <a:rPr sz="3000" b="1" dirty="0" err="1">
                 <a:solidFill>
                   <a:srgbClr val="000000"/>
                 </a:solidFill>
+                <a:latin typeface="+mj-lt"/>
+                <a:ea typeface="+mj-ea"/>
+                <a:cs typeface="+mj-cs"/>
               </a:rPr>
               <a:t>emory</a:t>
             </a:r>
             <a:r>
-              <a:rPr lang="en-AU" sz="3200" dirty="0">
+              <a:rPr lang="en-AU" sz="3000" b="1" dirty="0">
                 <a:solidFill>
                   <a:srgbClr val="000000"/>
                 </a:solidFill>
+                <a:latin typeface="+mj-lt"/>
+                <a:ea typeface="+mj-ea"/>
+                <a:cs typeface="+mj-cs"/>
               </a:rPr>
               <a:t> overcommitment</a:t>
             </a:r>
-            <a:endParaRPr sz="3200" dirty="0">
+            <a:endParaRPr sz="3000" b="1" dirty="0">
               <a:solidFill>
                 <a:srgbClr val="000000"/>
               </a:solidFill>
+              <a:latin typeface="+mj-lt"/>
+              <a:ea typeface="+mj-ea"/>
+              <a:cs typeface="+mj-cs"/>
             </a:endParaRPr>
           </a:p>
         </p:txBody>
@@ -26257,7 +26342,23 @@
                   <a:srgbClr val="000000"/>
                 </a:solidFill>
               </a:rPr>
-              <a:t>32 GB</a:t>
+              <a:t>32 G</a:t>
+            </a:r>
+            <a:r>
+              <a:rPr lang="en-AU" sz="1700" b="1" dirty="0" err="1">
+                <a:solidFill>
+                  <a:srgbClr val="000000"/>
+                </a:solidFill>
+              </a:rPr>
+              <a:t>i</a:t>
+            </a:r>
+            <a:r>
+              <a:rPr sz="1700" b="1" dirty="0">
+                <a:solidFill>
+                  <a:srgbClr val="000000"/>
+                </a:solidFill>
+              </a:rPr>
+              <a:t>B</a:t>
             </a:r>
           </a:p>
         </p:txBody>
@@ -26508,7 +26609,7 @@
                 </a:solidFill>
                 <a:latin typeface="+mn-lt"/>
               </a:rPr>
-              <a:t>Not every guest physical memory page is mapped to a host physical memory page. </a:t>
+              <a:t>Not every guest physical page is mapped to a host physical page. </a:t>
             </a:r>
           </a:p>
         </p:txBody>
@@ -26552,7 +26653,7 @@
         <p:spPr>
           <a:xfrm>
             <a:off x="594360" y="220563"/>
-            <a:ext cx="2367956" cy="584775"/>
+            <a:ext cx="2082045" cy="553998"/>
           </a:xfrm>
           <a:prstGeom prst="rect">
             <a:avLst/>
@@ -26567,17 +26668,23 @@
           <a:p>
             <a:pPr algn="l"/>
             <a:r>
-              <a:rPr lang="en-AU" sz="3200" dirty="0">
+              <a:rPr lang="en-AU" sz="3000" b="1" dirty="0">
                 <a:solidFill>
                   <a:srgbClr val="000000"/>
                 </a:solidFill>
+                <a:latin typeface="+mj-lt"/>
+                <a:ea typeface="+mj-ea"/>
+                <a:cs typeface="+mj-cs"/>
               </a:rPr>
               <a:t>VM isolation</a:t>
             </a:r>
-            <a:endParaRPr sz="3200" dirty="0">
+            <a:endParaRPr sz="3000" b="1" dirty="0">
               <a:solidFill>
                 <a:srgbClr val="000000"/>
               </a:solidFill>
+              <a:latin typeface="+mj-lt"/>
+              <a:ea typeface="+mj-ea"/>
+              <a:cs typeface="+mj-cs"/>
             </a:endParaRPr>
           </a:p>
         </p:txBody>
@@ -26657,7 +26764,23 @@
                   <a:srgbClr val="000000"/>
                 </a:solidFill>
               </a:rPr>
-              <a:t>B guest memory</a:t>
+              <a:t>B guest </a:t>
+            </a:r>
+            <a:r>
+              <a:rPr lang="en-AU" sz="1400" b="1" dirty="0">
+                <a:solidFill>
+                  <a:srgbClr val="000000"/>
+                </a:solidFill>
+              </a:rPr>
+              <a:t>physical </a:t>
+            </a:r>
+            <a:r>
+              <a:rPr sz="1400" b="1" dirty="0">
+                <a:solidFill>
+                  <a:srgbClr val="000000"/>
+                </a:solidFill>
+              </a:rPr>
+              <a:t>memory</a:t>
             </a:r>
           </a:p>
         </p:txBody>
@@ -26737,7 +26860,23 @@
                   <a:srgbClr val="000000"/>
                 </a:solidFill>
               </a:rPr>
-              <a:t>B guest memory</a:t>
+              <a:t>B guest </a:t>
+            </a:r>
+            <a:r>
+              <a:rPr lang="en-AU" sz="1400" b="1" dirty="0">
+                <a:solidFill>
+                  <a:srgbClr val="000000"/>
+                </a:solidFill>
+              </a:rPr>
+              <a:t>physical </a:t>
+            </a:r>
+            <a:r>
+              <a:rPr sz="1400" b="1" dirty="0">
+                <a:solidFill>
+                  <a:srgbClr val="000000"/>
+                </a:solidFill>
+              </a:rPr>
+              <a:t>memory</a:t>
             </a:r>
           </a:p>
         </p:txBody>
@@ -26817,7 +26956,23 @@
                   <a:srgbClr val="000000"/>
                 </a:solidFill>
               </a:rPr>
-              <a:t>B guest memory</a:t>
+              <a:t>B guest</a:t>
+            </a:r>
+            <a:r>
+              <a:rPr lang="en-AU" sz="1400" b="1" dirty="0">
+                <a:solidFill>
+                  <a:srgbClr val="000000"/>
+                </a:solidFill>
+              </a:rPr>
+              <a:t> physical</a:t>
+            </a:r>
+            <a:r>
+              <a:rPr sz="1400" b="1" dirty="0">
+                <a:solidFill>
+                  <a:srgbClr val="000000"/>
+                </a:solidFill>
+              </a:rPr>
+              <a:t> memory</a:t>
             </a:r>
           </a:p>
         </p:txBody>
@@ -27026,7 +27181,23 @@
                   <a:srgbClr val="000000"/>
                 </a:solidFill>
               </a:rPr>
-              <a:t>Host page</a:t>
+              <a:t>Host </a:t>
+            </a:r>
+            <a:r>
+              <a:rPr lang="en-AU" sz="1300" b="0" dirty="0">
+                <a:solidFill>
+                  <a:srgbClr val="000000"/>
+                </a:solidFill>
+              </a:rPr>
+              <a:t>physical </a:t>
+            </a:r>
+            <a:r>
+              <a:rPr sz="1300" b="0" dirty="0">
+                <a:solidFill>
+                  <a:srgbClr val="000000"/>
+                </a:solidFill>
+              </a:rPr>
+              <a:t>page</a:t>
             </a:r>
             <a:r>
               <a:rPr lang="en-AU" sz="1300" b="0" dirty="0">
@@ -27085,14 +27256,29 @@
           <a:bodyPr lIns="54864" tIns="36576" rIns="54864" bIns="36576" rtlCol="0" anchor="ctr"/>
           <a:lstStyle/>
           <a:p>
-            <a:pPr algn="ctr"/>
             <a:r>
               <a:rPr sz="1300" b="0" dirty="0">
                 <a:solidFill>
                   <a:srgbClr val="000000"/>
                 </a:solidFill>
               </a:rPr>
-              <a:t>Host page</a:t>
+              <a:t>Host</a:t>
+            </a:r>
+            <a:r>
+              <a:rPr lang="en-AU" sz="1300" dirty="0">
+                <a:solidFill>
+                  <a:srgbClr val="000000"/>
+                </a:solidFill>
+              </a:rPr>
+              <a:t> physical</a:t>
+            </a:r>
+            <a:r>
+              <a:rPr sz="1300" b="0" dirty="0">
+                <a:solidFill>
+                  <a:srgbClr val="000000"/>
+                </a:solidFill>
+              </a:rPr>
+              <a:t> page</a:t>
             </a:r>
             <a:r>
               <a:rPr lang="en-AU" sz="1300" dirty="0">
@@ -27151,14 +27337,29 @@
           <a:bodyPr lIns="54864" tIns="36576" rIns="54864" bIns="36576" rtlCol="0" anchor="ctr"/>
           <a:lstStyle/>
           <a:p>
-            <a:pPr algn="ctr"/>
             <a:r>
               <a:rPr sz="1300" b="0" dirty="0">
                 <a:solidFill>
                   <a:srgbClr val="000000"/>
                 </a:solidFill>
               </a:rPr>
-              <a:t>Host </a:t>
+              <a:t>Host</a:t>
+            </a:r>
+            <a:r>
+              <a:rPr lang="en-AU" sz="1300" dirty="0">
+                <a:solidFill>
+                  <a:srgbClr val="000000"/>
+                </a:solidFill>
+              </a:rPr>
+              <a:t> physical</a:t>
+            </a:r>
+            <a:r>
+              <a:rPr sz="1300" b="0" dirty="0">
+                <a:solidFill>
+                  <a:srgbClr val="000000"/>
+                </a:solidFill>
+              </a:rPr>
+              <a:t> </a:t>
             </a:r>
             <a:r>
               <a:rPr sz="1300" b="0" dirty="0" err="1">
@@ -27991,7 +28192,7 @@
         </p:style>
         <p:txBody>
           <a:bodyPr wrap="square" rtlCol="0" anchor="ctr">
-            <a:normAutofit fontScale="92500"/>
+            <a:normAutofit lnSpcReduction="10000"/>
           </a:bodyPr>
           <a:lstStyle/>
           <a:p>
@@ -28042,7 +28243,7 @@
                   <a:srgbClr val="000000"/>
                 </a:solidFill>
               </a:rPr>
-              <a:t>physical memory page</a:t>
+              <a:t>physical page</a:t>
             </a:r>
             <a:endParaRPr sz="1600" b="1" dirty="0">
               <a:solidFill>
@@ -28127,8 +28328,8 @@
         </p:nvSpPr>
         <p:spPr>
           <a:xfrm>
-            <a:off x="512700" y="105818"/>
-            <a:ext cx="3820918" cy="584775"/>
+            <a:off x="386384" y="105818"/>
+            <a:ext cx="3194721" cy="553998"/>
           </a:xfrm>
           <a:prstGeom prst="rect">
             <a:avLst/>
@@ -28141,11 +28342,15 @@
           </a:bodyPr>
           <a:lstStyle/>
           <a:p>
-            <a:r>
-              <a:rPr sz="3200" dirty="0">
+            <a:pPr algn="l"/>
+            <a:r>
+              <a:rPr sz="3000" b="1" dirty="0">
                 <a:solidFill>
                   <a:srgbClr val="000000"/>
                 </a:solidFill>
+                <a:latin typeface="+mj-lt"/>
+                <a:ea typeface="+mj-ea"/>
+                <a:cs typeface="+mj-cs"/>
               </a:rPr>
               <a:t>Extended page fault</a:t>
             </a:r>
@@ -28190,8 +28395,8 @@
         </p:nvSpPr>
         <p:spPr>
           <a:xfrm>
-            <a:off x="578623" y="319452"/>
-            <a:ext cx="6397778" cy="584775"/>
+            <a:off x="377382" y="319452"/>
+            <a:ext cx="5258619" cy="553998"/>
           </a:xfrm>
           <a:prstGeom prst="rect">
             <a:avLst/>
@@ -28204,35 +28409,48 @@
           </a:bodyPr>
           <a:lstStyle/>
           <a:p>
-            <a:r>
-              <a:rPr sz="3200" dirty="0">
+            <a:pPr algn="l"/>
+            <a:r>
+              <a:rPr sz="3000" b="1" dirty="0">
                 <a:solidFill>
                   <a:srgbClr val="000000"/>
                 </a:solidFill>
+                <a:latin typeface="+mj-lt"/>
+                <a:ea typeface="+mj-ea"/>
+                <a:cs typeface="+mj-cs"/>
               </a:rPr>
               <a:t>Page fault vs. </a:t>
             </a:r>
             <a:r>
-              <a:rPr lang="en-AU" sz="3200" dirty="0">
+              <a:rPr lang="en-AU" sz="3000" b="1" dirty="0">
                 <a:solidFill>
                   <a:srgbClr val="000000"/>
                 </a:solidFill>
+                <a:latin typeface="+mj-lt"/>
+                <a:ea typeface="+mj-ea"/>
+                <a:cs typeface="+mj-cs"/>
               </a:rPr>
               <a:t>E</a:t>
             </a:r>
             <a:r>
-              <a:rPr sz="3200" dirty="0" err="1">
+              <a:rPr sz="3000" b="1" dirty="0" err="1">
                 <a:solidFill>
                   <a:srgbClr val="000000"/>
                 </a:solidFill>
+                <a:latin typeface="+mj-lt"/>
+                <a:ea typeface="+mj-ea"/>
+                <a:cs typeface="+mj-cs"/>
               </a:rPr>
               <a:t>xtended</a:t>
             </a:r>
             <a:r>
-              <a:rPr sz="3200" dirty="0">
+              <a:rPr sz="3000" b="1" dirty="0">
                 <a:solidFill>
                   <a:srgbClr val="000000"/>
                 </a:solidFill>
+                <a:latin typeface="+mj-lt"/>
+                <a:ea typeface="+mj-ea"/>
+                <a:cs typeface="+mj-cs"/>
               </a:rPr>
               <a:t> page fault</a:t>
             </a:r>
@@ -28790,7 +29008,7 @@
         </p:style>
         <p:txBody>
           <a:bodyPr wrap="square" rtlCol="0" anchor="ctr">
-            <a:normAutofit fontScale="92500"/>
+            <a:normAutofit lnSpcReduction="10000"/>
           </a:bodyPr>
           <a:lstStyle/>
           <a:p>
@@ -28841,7 +29059,7 @@
                   <a:srgbClr val="000000"/>
                 </a:solidFill>
               </a:rPr>
-              <a:t>physical memory page</a:t>
+              <a:t>physical page</a:t>
             </a:r>
             <a:endParaRPr sz="1600" b="1" dirty="0">
               <a:solidFill>
@@ -28959,7 +29177,7 @@
         <p:spPr>
           <a:xfrm>
             <a:off x="820947" y="155005"/>
-            <a:ext cx="6230782" cy="1325563"/>
+            <a:ext cx="5820485" cy="1325563"/>
           </a:xfrm>
         </p:spPr>
         <p:txBody>
@@ -28968,8 +29186,25 @@
           </a:bodyPr>
           <a:lstStyle/>
           <a:p>
-            <a:r>
-              <a:rPr lang="en-US" sz="3200" b="1" dirty="0"/>
+            <a:pPr fontAlgn="base">
+              <a:spcBef>
+                <a:spcPct val="20000"/>
+              </a:spcBef>
+              <a:spcAft>
+                <a:spcPct val="0"/>
+              </a:spcAft>
+              <a:buClr>
+                <a:schemeClr val="hlink"/>
+              </a:buClr>
+              <a:buSzPct val="55000"/>
+              <a:buFont typeface="Wingdings" pitchFamily="2" charset="2"/>
+            </a:pPr>
+            <a:r>
+              <a:rPr lang="en-US" sz="3200" b="1" dirty="0">
+                <a:solidFill>
+                  <a:srgbClr val="000000"/>
+                </a:solidFill>
+              </a:rPr>
               <a:t>What is hardware virtualization?</a:t>
             </a:r>
           </a:p>
@@ -30467,7 +30702,7 @@
             </a:pPr>
             <a:r>
               <a:rPr lang="en-US" dirty="0"/>
-              <a:t>Install as an application on an existing host OS, </a:t>
+              <a:t>VMM or Hypervisor is installed as an application on an existing host OS, </a:t>
             </a:r>
             <a:r>
               <a:rPr lang="en-US" i="1" dirty="0"/>
@@ -30512,7 +30747,7 @@
                   <a:srgbClr val="FF0000"/>
                 </a:solidFill>
               </a:rPr>
-              <a:t>Which is the most privileges software? Host OS or Hosted hypervisor? </a:t>
+              <a:t>Which is the most privileged software? Host OS or Hosted hypervisor? </a:t>
             </a:r>
           </a:p>
           <a:p>
@@ -37023,7 +37258,7 @@
                 <a:ea typeface="+mn-ea"/>
                 <a:cs typeface="+mn-cs"/>
               </a:rPr>
-              <a:t>at a local computer on</a:t>
+              <a:t>at a local OS on</a:t>
             </a:r>
             <a:r>
               <a:rPr lang="en-US" sz="2400" dirty="0">
@@ -37856,7 +38091,7 @@
             </a:r>
             <a:r>
               <a:rPr lang="en-US" sz="2400" dirty="0"/>
-              <a:t> structure of attributes within a single attribute, </a:t>
+              <a:t> structure of attributes, </a:t>
             </a:r>
             <a:r>
               <a:rPr lang="en-AU" sz="2400" dirty="0"/>
@@ -46546,7 +46781,7 @@
             </a:pPr>
             <a:r>
               <a:rPr lang="en-AU" sz="2200" dirty="0"/>
-              <a:t>Q3: </a:t>
+              <a:t>Q2: </a:t>
             </a:r>
             <a:r>
               <a:rPr lang="en-US" sz="2200" dirty="0"/>
@@ -46658,7 +46893,7 @@
           <a:p>
             <a:r>
               <a:rPr lang="en-AU" sz="2800" dirty="0"/>
-              <a:t>The exam has a time limit of 6</a:t>
+              <a:t>The test has a time limit of 6</a:t>
             </a:r>
             <a:r>
               <a:rPr lang="en-AU" dirty="0"/>
@@ -46668,7 +46903,7 @@
           <a:p>
             <a:r>
               <a:rPr lang="en-AU" sz="2800" dirty="0"/>
-              <a:t>The exam is at </a:t>
+              <a:t>The test is at </a:t>
             </a:r>
             <a:r>
               <a:rPr lang="en-AU" sz="2800" dirty="0">
@@ -50756,7 +50991,7 @@
             </a:r>
             <a:r>
               <a:rPr dirty="0"/>
-              <a:t>page-aligned addresses are </a:t>
+              <a:t>page-aligned addresses </a:t>
             </a:r>
             <a:r>
               <a:rPr lang="en-US" dirty="0"/>

</xml_diff>